<commit_message>
recover: content, outreach drafts and tooling from 2026-08-08 to 08-17
</commit_message>
<xml_diff>
--- a/orcx_relayshield_demo_proposal.pptx
+++ b/orcx_relayshield_demo_proposal.pptx
@@ -11,6 +11,7 @@
     <p:sldId id="259" r:id="rId5"/>
     <p:sldId id="260" r:id="rId6"/>
     <p:sldId id="261" r:id="rId7"/>
+    <p:sldId id="263" r:id="rId14"/>
     <p:sldId id="262" r:id="rId8"/>
   </p:sldIdLst>
   <p:notesMasterIdLst>
@@ -6799,6 +6800,713 @@
 </file>
 
 <file path=ppt/slides/slide7.xml><?xml version="1.0" encoding="utf-8"?>
+<p:sld xmlns:a="http://schemas.openxmlformats.org/drawingml/2006/main" xmlns:p="http://schemas.openxmlformats.org/presentationml/2006/main" xmlns:r="http://schemas.openxmlformats.org/officeDocument/2006/relationships">
+  <p:cSld>
+    <p:bg>
+      <p:bgPr>
+        <a:solidFill>
+          <a:srgbClr val="EDF1FA"/>
+        </a:solidFill>
+      </p:bgPr>
+    </p:bg>
+    <p:spTree>
+      <p:nvGrpSpPr>
+        <p:cNvPr id="1" name=""/>
+        <p:cNvGrpSpPr/>
+        <p:nvPr/>
+      </p:nvGrpSpPr>
+      <p:grpSpPr/>
+      <p:sp>
+        <p:nvSpPr>
+          <p:cNvPr id="2" name="Text 0"/>
+          <p:cNvSpPr/>
+          <p:nvPr/>
+        </p:nvSpPr>
+        <p:spPr>
+          <a:xfrm>
+            <a:off x="640080" y="457200"/>
+            <a:ext cx="8229600" cy="594360"/>
+          </a:xfrm>
+          <a:prstGeom prst="rect">
+            <a:avLst/>
+          </a:prstGeom>
+          <a:noFill/>
+          <a:ln/>
+        </p:spPr>
+        <p:txBody>
+          <a:bodyPr wrap="square" rtlCol="0" anchor="ctr"/>
+          <a:lstStyle/>
+          <a:p>
+            <a:pPr indent="0" marL="0">
+              <a:buNone/>
+            </a:pPr>
+            <a:r>
+              <a:rPr lang="en-US" sz="3000" b="1" dirty="0">
+                <a:solidFill>
+                  <a:srgbClr val="1A2138"/>
+                </a:solidFill>
+                <a:latin typeface="Cambria" pitchFamily="34" charset="0"/>
+                <a:ea typeface="Cambria" pitchFamily="34" charset="-122"/>
+                <a:cs typeface="Cambria" pitchFamily="34" charset="-120"/>
+              </a:rPr>
+              <a:t>How we'll know the demo worked</a:t>
+            </a:r>
+            <a:endParaRPr lang="en-US" sz="3000" dirty="0"/>
+          </a:p>
+        </p:txBody>
+      </p:sp>
+      <p:sp>
+        <p:nvSpPr>
+          <p:cNvPr id="3" name="Text 1"/>
+          <p:cNvSpPr/>
+          <p:nvPr/>
+        </p:nvSpPr>
+        <p:spPr>
+          <a:xfrm>
+            <a:off x="640080" y="1051560"/>
+            <a:ext cx="9875520" cy="411480"/>
+          </a:xfrm>
+          <a:prstGeom prst="rect">
+            <a:avLst/>
+          </a:prstGeom>
+          <a:noFill/>
+          <a:ln/>
+        </p:spPr>
+        <p:txBody>
+          <a:bodyPr wrap="square" rtlCol="0" anchor="ctr"/>
+          <a:lstStyle/>
+          <a:p>
+            <a:pPr indent="0" marL="0">
+              <a:buNone/>
+            </a:pPr>
+            <a:r>
+              <a:rPr lang="en-US" sz="1350" dirty="0">
+                <a:solidFill>
+                  <a:srgbClr val="7C88A6"/>
+                </a:solidFill>
+                <a:latin typeface="Calibri" pitchFamily="34" charset="0"/>
+                <a:ea typeface="Calibri" pitchFamily="34" charset="-122"/>
+                <a:cs typeface="Calibri" pitchFamily="34" charset="-120"/>
+              </a:rPr>
+              <a:t>Four criteria, agreed before we start. One of them can genuinely fail, and that is deliberate.</a:t>
+            </a:r>
+            <a:endParaRPr lang="en-US" sz="1350" dirty="0"/>
+          </a:p>
+        </p:txBody>
+      </p:sp>
+      <p:sp>
+        <p:nvSpPr>
+          <p:cNvPr id="4" name="Shape 2"/>
+          <p:cNvSpPr/>
+          <p:nvPr/>
+        </p:nvSpPr>
+        <p:spPr>
+          <a:xfrm>
+            <a:off x="640080" y="1874520"/>
+            <a:ext cx="10881360" cy="859536"/>
+          </a:xfrm>
+          <a:prstGeom prst="roundRect">
+            <a:avLst>
+              <a:gd name="adj" fmla="val 10638"/>
+            </a:avLst>
+          </a:prstGeom>
+          <a:solidFill>
+            <a:srgbClr val="FFFFFF"/>
+          </a:solidFill>
+          <a:ln/>
+          <a:effectLst>
+            <a:outerShdw sx="100000" sy="100000" kx="0" ky="0" algn="bl" rotWithShape="0" blurRad="76200" dist="25400" dir="5400000">
+              <a:srgbClr val="0B0F1F">
+                <a:alpha val="15000"/>
+              </a:srgbClr>
+            </a:outerShdw>
+          </a:effectLst>
+        </p:spPr>
+      </p:sp>
+      <p:sp>
+        <p:nvSpPr>
+          <p:cNvPr id="5" name="Shape 3"/>
+          <p:cNvSpPr/>
+          <p:nvPr/>
+        </p:nvSpPr>
+        <p:spPr>
+          <a:xfrm>
+            <a:off x="914400" y="2011680"/>
+            <a:ext cx="585216" cy="585216"/>
+          </a:xfrm>
+          <a:prstGeom prst="ellipse">
+            <a:avLst/>
+          </a:prstGeom>
+          <a:solidFill>
+            <a:srgbClr val="FF6D5A"/>
+          </a:solidFill>
+          <a:ln/>
+        </p:spPr>
+      </p:sp>
+      <p:pic>
+        <p:nvPicPr>
+          <p:cNvPr id="6" name="Image 0" descr="preencoded.png">    </p:cNvPr>
+          <p:cNvPicPr>
+            <a:picLocks noChangeAspect="1"/>
+          </p:cNvPicPr>
+          <p:nvPr/>
+        </p:nvPicPr>
+        <p:blipFill>
+          <a:blip r:embed="rId2"/>
+          <a:stretch>
+            <a:fillRect/>
+          </a:stretch>
+        </p:blipFill>
+        <p:spPr>
+          <a:xfrm>
+            <a:off x="1049000" y="2146280"/>
+            <a:ext cx="316017" cy="316017"/>
+          </a:xfrm>
+          <a:prstGeom prst="rect">
+            <a:avLst/>
+          </a:prstGeom>
+        </p:spPr>
+      </p:pic>
+      <p:sp>
+        <p:nvSpPr>
+          <p:cNvPr id="7" name="Text 4"/>
+          <p:cNvSpPr/>
+          <p:nvPr/>
+        </p:nvSpPr>
+        <p:spPr>
+          <a:xfrm>
+            <a:off x="1737360" y="1965960"/>
+            <a:ext cx="9509760" cy="329184"/>
+          </a:xfrm>
+          <a:prstGeom prst="rect">
+            <a:avLst/>
+          </a:prstGeom>
+          <a:noFill/>
+          <a:ln/>
+        </p:spPr>
+        <p:txBody>
+          <a:bodyPr wrap="square" rtlCol="0" anchor="ctr"/>
+          <a:lstStyle/>
+          <a:p>
+            <a:pPr indent="0" marL="0">
+              <a:buNone/>
+            </a:pPr>
+            <a:r>
+              <a:rPr lang="en-US" sz="1450" b="1" dirty="0">
+                <a:solidFill>
+                  <a:srgbClr val="1A2138"/>
+                </a:solidFill>
+                <a:latin typeface="Calibri" pitchFamily="34" charset="0"/>
+                <a:ea typeface="Calibri" pitchFamily="34" charset="-122"/>
+                <a:cs typeface="Calibri" pitchFamily="34" charset="-120"/>
+              </a:rPr>
+              <a:t>All three calls run inside Quantum's own flow</a:t>
+            </a:r>
+            <a:endParaRPr lang="en-US" sz="1450" dirty="0"/>
+          </a:p>
+        </p:txBody>
+      </p:sp>
+      <p:sp>
+        <p:nvSpPr>
+          <p:cNvPr id="8" name="Text 5"/>
+          <p:cNvSpPr/>
+          <p:nvPr/>
+        </p:nvSpPr>
+        <p:spPr>
+          <a:xfrm>
+            <a:off x="1737360" y="2295144"/>
+            <a:ext cx="9509760" cy="411480"/>
+          </a:xfrm>
+          <a:prstGeom prst="rect">
+            <a:avLst/>
+          </a:prstGeom>
+          <a:noFill/>
+          <a:ln/>
+        </p:spPr>
+        <p:txBody>
+          <a:bodyPr wrap="square" rtlCol="0" anchor="ctr"/>
+          <a:lstStyle/>
+          <a:p>
+            <a:pPr indent="0" marL="0">
+              <a:buNone/>
+            </a:pPr>
+            <a:r>
+              <a:rPr lang="en-US" sz="1150" dirty="0">
+                <a:solidFill>
+                  <a:srgbClr val="5B6B8C"/>
+                </a:solidFill>
+                <a:latin typeface="Calibri" pitchFamily="34" charset="0"/>
+                <a:ea typeface="Calibri" pitchFamily="34" charset="-122"/>
+                <a:cs typeface="Calibri" pitchFamily="34" charset="-120"/>
+              </a:rPr>
+              <a:t>Not a RelayShield demo script. The calls fire from your policy engine, against your own object model, in the live working session with Gary.</a:t>
+            </a:r>
+            <a:endParaRPr lang="en-US" sz="1150" dirty="0"/>
+          </a:p>
+        </p:txBody>
+      </p:sp>
+      <p:sp>
+        <p:nvSpPr>
+          <p:cNvPr id="9" name="Shape 6"/>
+          <p:cNvSpPr/>
+          <p:nvPr/>
+        </p:nvSpPr>
+        <p:spPr>
+          <a:xfrm>
+            <a:off x="640080" y="2898648"/>
+            <a:ext cx="10881360" cy="859536"/>
+          </a:xfrm>
+          <a:prstGeom prst="roundRect">
+            <a:avLst>
+              <a:gd name="adj" fmla="val 10638"/>
+            </a:avLst>
+          </a:prstGeom>
+          <a:solidFill>
+            <a:srgbClr val="FFFFFF"/>
+          </a:solidFill>
+          <a:ln/>
+          <a:effectLst>
+            <a:outerShdw sx="100000" sy="100000" kx="0" ky="0" algn="bl" rotWithShape="0" blurRad="76200" dist="25400" dir="5400000">
+              <a:srgbClr val="0B0F1F">
+                <a:alpha val="15000"/>
+              </a:srgbClr>
+            </a:outerShdw>
+          </a:effectLst>
+        </p:spPr>
+      </p:sp>
+      <p:sp>
+        <p:nvSpPr>
+          <p:cNvPr id="10" name="Shape 7"/>
+          <p:cNvSpPr/>
+          <p:nvPr/>
+        </p:nvSpPr>
+        <p:spPr>
+          <a:xfrm>
+            <a:off x="914400" y="3035808"/>
+            <a:ext cx="585216" cy="585216"/>
+          </a:xfrm>
+          <a:prstGeom prst="ellipse">
+            <a:avLst/>
+          </a:prstGeom>
+          <a:solidFill>
+            <a:srgbClr val="FF6D5A"/>
+          </a:solidFill>
+          <a:ln/>
+        </p:spPr>
+      </p:sp>
+      <p:pic>
+        <p:nvPicPr>
+          <p:cNvPr id="11" name="Image 1" descr="preencoded.png">    </p:cNvPr>
+          <p:cNvPicPr>
+            <a:picLocks noChangeAspect="1"/>
+          </p:cNvPicPr>
+          <p:nvPr/>
+        </p:nvPicPr>
+        <p:blipFill>
+          <a:blip r:embed="rId3"/>
+          <a:stretch>
+            <a:fillRect/>
+          </a:stretch>
+        </p:blipFill>
+        <p:spPr>
+          <a:xfrm>
+            <a:off x="1049000" y="3170408"/>
+            <a:ext cx="316017" cy="316017"/>
+          </a:xfrm>
+          <a:prstGeom prst="rect">
+            <a:avLst/>
+          </a:prstGeom>
+        </p:spPr>
+      </p:pic>
+      <p:sp>
+        <p:nvSpPr>
+          <p:cNvPr id="12" name="Text 8"/>
+          <p:cNvSpPr/>
+          <p:nvPr/>
+        </p:nvSpPr>
+        <p:spPr>
+          <a:xfrm>
+            <a:off x="1737360" y="2990088"/>
+            <a:ext cx="9509760" cy="329184"/>
+          </a:xfrm>
+          <a:prstGeom prst="rect">
+            <a:avLst/>
+          </a:prstGeom>
+          <a:noFill/>
+          <a:ln/>
+        </p:spPr>
+        <p:txBody>
+          <a:bodyPr wrap="square" rtlCol="0" anchor="ctr"/>
+          <a:lstStyle/>
+          <a:p>
+            <a:pPr indent="0" marL="0">
+              <a:buNone/>
+            </a:pPr>
+            <a:r>
+              <a:rPr lang="en-US" sz="1450" b="1" dirty="0">
+                <a:solidFill>
+                  <a:srgbClr val="1A2138"/>
+                </a:solidFill>
+                <a:latin typeface="Calibri" pitchFamily="34" charset="0"/>
+                <a:ea typeface="Calibri" pitchFamily="34" charset="-122"/>
+                <a:cs typeface="Calibri" pitchFamily="34" charset="-120"/>
+              </a:rPr>
+              <a:t>At least one upstream finding with no matching in-session behavior</a:t>
+            </a:r>
+            <a:endParaRPr lang="en-US" sz="1450" dirty="0"/>
+          </a:p>
+        </p:txBody>
+      </p:sp>
+      <p:sp>
+        <p:nvSpPr>
+          <p:cNvPr id="13" name="Text 9"/>
+          <p:cNvSpPr/>
+          <p:nvPr/>
+        </p:nvSpPr>
+        <p:spPr>
+          <a:xfrm>
+            <a:off x="1737360" y="3319272"/>
+            <a:ext cx="9509760" cy="411480"/>
+          </a:xfrm>
+          <a:prstGeom prst="rect">
+            <a:avLst/>
+          </a:prstGeom>
+          <a:noFill/>
+          <a:ln/>
+        </p:spPr>
+        <p:txBody>
+          <a:bodyPr wrap="square" rtlCol="0" anchor="ctr"/>
+          <a:lstStyle/>
+          <a:p>
+            <a:pPr indent="0" marL="0">
+              <a:buNone/>
+            </a:pPr>
+            <a:r>
+              <a:rPr lang="en-US" sz="1150" dirty="0">
+                <a:solidFill>
+                  <a:srgbClr val="5B6B8C"/>
+                </a:solidFill>
+                <a:latin typeface="Calibri" pitchFamily="34" charset="0"/>
+                <a:ea typeface="Calibri" pitchFamily="34" charset="-122"/>
+                <a:cs typeface="Calibri" pitchFamily="34" charset="-120"/>
+              </a:rPr>
+              <a:t>The entire premise of this deck. If 90 days pass without one, the integration has not proven its case, and both sides should know that plainly.</a:t>
+            </a:r>
+            <a:endParaRPr lang="en-US" sz="1150" dirty="0"/>
+          </a:p>
+        </p:txBody>
+      </p:sp>
+      <p:sp>
+        <p:nvSpPr>
+          <p:cNvPr id="14" name="Shape 10"/>
+          <p:cNvSpPr/>
+          <p:nvPr/>
+        </p:nvSpPr>
+        <p:spPr>
+          <a:xfrm>
+            <a:off x="640080" y="3922776"/>
+            <a:ext cx="10881360" cy="859536"/>
+          </a:xfrm>
+          <a:prstGeom prst="roundRect">
+            <a:avLst>
+              <a:gd name="adj" fmla="val 10638"/>
+            </a:avLst>
+          </a:prstGeom>
+          <a:solidFill>
+            <a:srgbClr val="FFFFFF"/>
+          </a:solidFill>
+          <a:ln/>
+          <a:effectLst>
+            <a:outerShdw sx="100000" sy="100000" kx="0" ky="0" algn="bl" rotWithShape="0" blurRad="76200" dist="25400" dir="5400000">
+              <a:srgbClr val="0B0F1F">
+                <a:alpha val="15000"/>
+              </a:srgbClr>
+            </a:outerShdw>
+          </a:effectLst>
+        </p:spPr>
+      </p:sp>
+      <p:sp>
+        <p:nvSpPr>
+          <p:cNvPr id="15" name="Shape 11"/>
+          <p:cNvSpPr/>
+          <p:nvPr/>
+        </p:nvSpPr>
+        <p:spPr>
+          <a:xfrm>
+            <a:off x="914400" y="4059936"/>
+            <a:ext cx="585216" cy="585216"/>
+          </a:xfrm>
+          <a:prstGeom prst="ellipse">
+            <a:avLst/>
+          </a:prstGeom>
+          <a:solidFill>
+            <a:srgbClr val="FF6D5A"/>
+          </a:solidFill>
+          <a:ln/>
+        </p:spPr>
+      </p:sp>
+      <p:pic>
+        <p:nvPicPr>
+          <p:cNvPr id="16" name="Image 2" descr="preencoded.png">    </p:cNvPr>
+          <p:cNvPicPr>
+            <a:picLocks noChangeAspect="1"/>
+          </p:cNvPicPr>
+          <p:nvPr/>
+        </p:nvPicPr>
+        <p:blipFill>
+          <a:blip r:embed="rId5"/>
+          <a:stretch>
+            <a:fillRect/>
+          </a:stretch>
+        </p:blipFill>
+        <p:spPr>
+          <a:xfrm>
+            <a:off x="1049000" y="4194536"/>
+            <a:ext cx="316017" cy="316017"/>
+          </a:xfrm>
+          <a:prstGeom prst="rect">
+            <a:avLst/>
+          </a:prstGeom>
+        </p:spPr>
+      </p:pic>
+      <p:sp>
+        <p:nvSpPr>
+          <p:cNvPr id="17" name="Text 12"/>
+          <p:cNvSpPr/>
+          <p:nvPr/>
+        </p:nvSpPr>
+        <p:spPr>
+          <a:xfrm>
+            <a:off x="1737360" y="4014216"/>
+            <a:ext cx="9509760" cy="329184"/>
+          </a:xfrm>
+          <a:prstGeom prst="rect">
+            <a:avLst/>
+          </a:prstGeom>
+          <a:noFill/>
+          <a:ln/>
+        </p:spPr>
+        <p:txBody>
+          <a:bodyPr wrap="square" rtlCol="0" anchor="ctr"/>
+          <a:lstStyle/>
+          <a:p>
+            <a:pPr indent="0" marL="0">
+              <a:buNone/>
+            </a:pPr>
+            <a:r>
+              <a:rPr lang="en-US" sz="1450" b="1" dirty="0">
+                <a:solidFill>
+                  <a:srgbClr val="1A2138"/>
+                </a:solidFill>
+                <a:latin typeface="Calibri" pitchFamily="34" charset="0"/>
+                <a:ea typeface="Calibri" pitchFamily="34" charset="-122"/>
+                <a:cs typeface="Calibri" pitchFamily="34" charset="-120"/>
+              </a:rPr>
+              <a:t>A score change produces a different policy outcome</a:t>
+            </a:r>
+            <a:endParaRPr lang="en-US" sz="1450" dirty="0"/>
+          </a:p>
+        </p:txBody>
+      </p:sp>
+      <p:sp>
+        <p:nvSpPr>
+          <p:cNvPr id="18" name="Text 13"/>
+          <p:cNvSpPr/>
+          <p:nvPr/>
+        </p:nvSpPr>
+        <p:spPr>
+          <a:xfrm>
+            <a:off x="1737360" y="4343400"/>
+            <a:ext cx="9509760" cy="411480"/>
+          </a:xfrm>
+          <a:prstGeom prst="rect">
+            <a:avLst/>
+          </a:prstGeom>
+          <a:noFill/>
+          <a:ln/>
+        </p:spPr>
+        <p:txBody>
+          <a:bodyPr wrap="square" rtlCol="0" anchor="ctr"/>
+          <a:lstStyle/>
+          <a:p>
+            <a:pPr indent="0" marL="0">
+              <a:buNone/>
+            </a:pPr>
+            <a:r>
+              <a:rPr lang="en-US" sz="1150" dirty="0">
+                <a:solidFill>
+                  <a:srgbClr val="5B6B8C"/>
+                </a:solidFill>
+                <a:latin typeface="Calibri" pitchFamily="34" charset="0"/>
+                <a:ea typeface="Calibri" pitchFamily="34" charset="-122"/>
+                <a:cs typeface="Calibri" pitchFamily="34" charset="-120"/>
+              </a:rPr>
+              <a:t>The 58 to 84 escalation must move Quantum from elevate to terminate. If the policy decision is identical either way, the score is decoration.</a:t>
+            </a:r>
+            <a:endParaRPr lang="en-US" sz="1150" dirty="0"/>
+          </a:p>
+        </p:txBody>
+      </p:sp>
+      <p:sp>
+        <p:nvSpPr>
+          <p:cNvPr id="19" name="Shape 14"/>
+          <p:cNvSpPr/>
+          <p:nvPr/>
+        </p:nvSpPr>
+        <p:spPr>
+          <a:xfrm>
+            <a:off x="640080" y="4946904"/>
+            <a:ext cx="10881360" cy="859536"/>
+          </a:xfrm>
+          <a:prstGeom prst="roundRect">
+            <a:avLst>
+              <a:gd name="adj" fmla="val 10638"/>
+            </a:avLst>
+          </a:prstGeom>
+          <a:solidFill>
+            <a:srgbClr val="FFFFFF"/>
+          </a:solidFill>
+          <a:ln/>
+          <a:effectLst>
+            <a:outerShdw sx="100000" sy="100000" kx="0" ky="0" algn="bl" rotWithShape="0" blurRad="76200" dist="25400" dir="5400000">
+              <a:srgbClr val="0B0F1F">
+                <a:alpha val="15000"/>
+              </a:srgbClr>
+            </a:outerShdw>
+          </a:effectLst>
+        </p:spPr>
+      </p:sp>
+      <p:sp>
+        <p:nvSpPr>
+          <p:cNvPr id="20" name="Shape 15"/>
+          <p:cNvSpPr/>
+          <p:nvPr/>
+        </p:nvSpPr>
+        <p:spPr>
+          <a:xfrm>
+            <a:off x="914400" y="5084064"/>
+            <a:ext cx="585216" cy="585216"/>
+          </a:xfrm>
+          <a:prstGeom prst="ellipse">
+            <a:avLst/>
+          </a:prstGeom>
+          <a:solidFill>
+            <a:srgbClr val="FF6D5A"/>
+          </a:solidFill>
+          <a:ln/>
+        </p:spPr>
+      </p:sp>
+      <p:pic>
+        <p:nvPicPr>
+          <p:cNvPr id="21" name="Image 3" descr="preencoded.png">    </p:cNvPr>
+          <p:cNvPicPr>
+            <a:picLocks noChangeAspect="1"/>
+          </p:cNvPicPr>
+          <p:nvPr/>
+        </p:nvPicPr>
+        <p:blipFill>
+          <a:blip r:embed="rId4"/>
+          <a:stretch>
+            <a:fillRect/>
+          </a:stretch>
+        </p:blipFill>
+        <p:spPr>
+          <a:xfrm>
+            <a:off x="1049000" y="5218664"/>
+            <a:ext cx="316017" cy="316017"/>
+          </a:xfrm>
+          <a:prstGeom prst="rect">
+            <a:avLst/>
+          </a:prstGeom>
+        </p:spPr>
+      </p:pic>
+      <p:sp>
+        <p:nvSpPr>
+          <p:cNvPr id="22" name="Text 16"/>
+          <p:cNvSpPr/>
+          <p:nvPr/>
+        </p:nvSpPr>
+        <p:spPr>
+          <a:xfrm>
+            <a:off x="1737360" y="5038344"/>
+            <a:ext cx="9509760" cy="329184"/>
+          </a:xfrm>
+          <a:prstGeom prst="rect">
+            <a:avLst/>
+          </a:prstGeom>
+          <a:noFill/>
+          <a:ln/>
+        </p:spPr>
+        <p:txBody>
+          <a:bodyPr wrap="square" rtlCol="0" anchor="ctr"/>
+          <a:lstStyle/>
+          <a:p>
+            <a:pPr indent="0" marL="0">
+              <a:buNone/>
+            </a:pPr>
+            <a:r>
+              <a:rPr lang="en-US" sz="1450" b="1" dirty="0">
+                <a:solidFill>
+                  <a:srgbClr val="1A2138"/>
+                </a:solidFill>
+                <a:latin typeface="Calibri" pitchFamily="34" charset="0"/>
+                <a:ea typeface="Calibri" pitchFamily="34" charset="-122"/>
+                <a:cs typeface="Calibri" pitchFamily="34" charset="-120"/>
+              </a:rPr>
+              <a:t>Degraded is never reported as clean</a:t>
+            </a:r>
+            <a:endParaRPr lang="en-US" sz="1450" dirty="0"/>
+          </a:p>
+        </p:txBody>
+      </p:sp>
+      <p:sp>
+        <p:nvSpPr>
+          <p:cNvPr id="23" name="Text 17"/>
+          <p:cNvSpPr/>
+          <p:nvPr/>
+        </p:nvSpPr>
+        <p:spPr>
+          <a:xfrm>
+            <a:off x="1737360" y="5367528"/>
+            <a:ext cx="9509760" cy="411480"/>
+          </a:xfrm>
+          <a:prstGeom prst="rect">
+            <a:avLst/>
+          </a:prstGeom>
+          <a:noFill/>
+          <a:ln/>
+        </p:spPr>
+        <p:txBody>
+          <a:bodyPr wrap="square" rtlCol="0" anchor="ctr"/>
+          <a:lstStyle/>
+          <a:p>
+            <a:pPr indent="0" marL="0">
+              <a:buNone/>
+            </a:pPr>
+            <a:r>
+              <a:rPr lang="en-US" sz="1150" dirty="0">
+                <a:solidFill>
+                  <a:srgbClr val="5B6B8C"/>
+                </a:solidFill>
+                <a:latin typeface="Calibri" pitchFamily="34" charset="0"/>
+                <a:ea typeface="Calibri" pitchFamily="34" charset="-122"/>
+                <a:cs typeface="Calibri" pitchFamily="34" charset="-120"/>
+              </a:rPr>
+              <a:t>Every unavailable source surfaces as degraded, never as a silent pass. This is the one failure mode that would make the feed unsafe to trust.</a:t>
+            </a:r>
+            <a:endParaRPr lang="en-US" sz="1150" dirty="0"/>
+          </a:p>
+        </p:txBody>
+      </p:sp>
+    </p:spTree>
+  </p:cSld>
+  <p:clrMapOvr>
+    <a:masterClrMapping/>
+  </p:clrMapOvr>
+</p:sld>
+</file>
+
+<file path=ppt/slides/slide8.xml><?xml version="1.0" encoding="utf-8"?>
 <p:sld xmlns:a="http://schemas.openxmlformats.org/drawingml/2006/main" xmlns:r="http://schemas.openxmlformats.org/officeDocument/2006/relationships" xmlns:p="http://schemas.openxmlformats.org/presentationml/2006/main">
   <p:cSld name="Slide 7">
     <p:bg>

</xml_diff>